<commit_message>
Infra, Kafka, architecture image 변경
</commit_message>
<xml_diff>
--- a/resource/Infra, Kafka, architecture.pptx
+++ b/resource/Infra, Kafka, architecture.pptx
@@ -8,6 +8,7 @@
     <p:sldId id="258" r:id="rId2"/>
     <p:sldId id="259" r:id="rId3"/>
     <p:sldId id="260" r:id="rId4"/>
+    <p:sldId id="261" r:id="rId5"/>
   </p:sldIdLst>
   <p:sldSz cx="12192000" cy="6858000"/>
   <p:notesSz cx="6858000" cy="9144000"/>
@@ -243,7 +244,7 @@
           <a:p>
             <a:fld id="{F690D3FD-2EC0-47C0-831C-8D6E4FC09FD9}" type="datetimeFigureOut">
               <a:rPr lang="ko-KR" altLang="en-US" smtClean="0"/>
-              <a:t>2024. 7. 9.</a:t>
+              <a:t>2024-11-05</a:t>
             </a:fld>
             <a:endParaRPr lang="ko-KR" altLang="en-US"/>
           </a:p>
@@ -411,7 +412,7 @@
           <a:p>
             <a:fld id="{F690D3FD-2EC0-47C0-831C-8D6E4FC09FD9}" type="datetimeFigureOut">
               <a:rPr lang="ko-KR" altLang="en-US" smtClean="0"/>
-              <a:t>2024. 7. 9.</a:t>
+              <a:t>2024-11-05</a:t>
             </a:fld>
             <a:endParaRPr lang="ko-KR" altLang="en-US"/>
           </a:p>
@@ -589,7 +590,7 @@
           <a:p>
             <a:fld id="{F690D3FD-2EC0-47C0-831C-8D6E4FC09FD9}" type="datetimeFigureOut">
               <a:rPr lang="ko-KR" altLang="en-US" smtClean="0"/>
-              <a:t>2024. 7. 9.</a:t>
+              <a:t>2024-11-05</a:t>
             </a:fld>
             <a:endParaRPr lang="ko-KR" altLang="en-US"/>
           </a:p>
@@ -757,7 +758,7 @@
           <a:p>
             <a:fld id="{F690D3FD-2EC0-47C0-831C-8D6E4FC09FD9}" type="datetimeFigureOut">
               <a:rPr lang="ko-KR" altLang="en-US" smtClean="0"/>
-              <a:t>2024. 7. 9.</a:t>
+              <a:t>2024-11-05</a:t>
             </a:fld>
             <a:endParaRPr lang="ko-KR" altLang="en-US"/>
           </a:p>
@@ -1002,7 +1003,7 @@
           <a:p>
             <a:fld id="{F690D3FD-2EC0-47C0-831C-8D6E4FC09FD9}" type="datetimeFigureOut">
               <a:rPr lang="ko-KR" altLang="en-US" smtClean="0"/>
-              <a:t>2024. 7. 9.</a:t>
+              <a:t>2024-11-05</a:t>
             </a:fld>
             <a:endParaRPr lang="ko-KR" altLang="en-US"/>
           </a:p>
@@ -1231,7 +1232,7 @@
           <a:p>
             <a:fld id="{F690D3FD-2EC0-47C0-831C-8D6E4FC09FD9}" type="datetimeFigureOut">
               <a:rPr lang="ko-KR" altLang="en-US" smtClean="0"/>
-              <a:t>2024. 7. 9.</a:t>
+              <a:t>2024-11-05</a:t>
             </a:fld>
             <a:endParaRPr lang="ko-KR" altLang="en-US"/>
           </a:p>
@@ -1595,7 +1596,7 @@
           <a:p>
             <a:fld id="{F690D3FD-2EC0-47C0-831C-8D6E4FC09FD9}" type="datetimeFigureOut">
               <a:rPr lang="ko-KR" altLang="en-US" smtClean="0"/>
-              <a:t>2024. 7. 9.</a:t>
+              <a:t>2024-11-05</a:t>
             </a:fld>
             <a:endParaRPr lang="ko-KR" altLang="en-US"/>
           </a:p>
@@ -1712,7 +1713,7 @@
           <a:p>
             <a:fld id="{F690D3FD-2EC0-47C0-831C-8D6E4FC09FD9}" type="datetimeFigureOut">
               <a:rPr lang="ko-KR" altLang="en-US" smtClean="0"/>
-              <a:t>2024. 7. 9.</a:t>
+              <a:t>2024-11-05</a:t>
             </a:fld>
             <a:endParaRPr lang="ko-KR" altLang="en-US"/>
           </a:p>
@@ -1807,7 +1808,7 @@
           <a:p>
             <a:fld id="{F690D3FD-2EC0-47C0-831C-8D6E4FC09FD9}" type="datetimeFigureOut">
               <a:rPr lang="ko-KR" altLang="en-US" smtClean="0"/>
-              <a:t>2024. 7. 9.</a:t>
+              <a:t>2024-11-05</a:t>
             </a:fld>
             <a:endParaRPr lang="ko-KR" altLang="en-US"/>
           </a:p>
@@ -2082,7 +2083,7 @@
           <a:p>
             <a:fld id="{F690D3FD-2EC0-47C0-831C-8D6E4FC09FD9}" type="datetimeFigureOut">
               <a:rPr lang="ko-KR" altLang="en-US" smtClean="0"/>
-              <a:t>2024. 7. 9.</a:t>
+              <a:t>2024-11-05</a:t>
             </a:fld>
             <a:endParaRPr lang="ko-KR" altLang="en-US"/>
           </a:p>
@@ -2334,7 +2335,7 @@
           <a:p>
             <a:fld id="{F690D3FD-2EC0-47C0-831C-8D6E4FC09FD9}" type="datetimeFigureOut">
               <a:rPr lang="ko-KR" altLang="en-US" smtClean="0"/>
-              <a:t>2024. 7. 9.</a:t>
+              <a:t>2024-11-05</a:t>
             </a:fld>
             <a:endParaRPr lang="ko-KR" altLang="en-US"/>
           </a:p>
@@ -2545,7 +2546,7 @@
           <a:p>
             <a:fld id="{F690D3FD-2EC0-47C0-831C-8D6E4FC09FD9}" type="datetimeFigureOut">
               <a:rPr lang="ko-KR" altLang="en-US" smtClean="0"/>
-              <a:t>2024. 7. 9.</a:t>
+              <a:t>2024-11-05</a:t>
             </a:fld>
             <a:endParaRPr lang="ko-KR" altLang="en-US"/>
           </a:p>
@@ -12455,50 +12456,6 @@
       </p:sp>
       <p:cxnSp>
         <p:nvCxnSpPr>
-          <p:cNvPr id="37" name="연결선: 구부러짐 36">
-            <a:extLst>
-              <a:ext uri="{FF2B5EF4-FFF2-40B4-BE49-F238E27FC236}">
-                <a16:creationId xmlns:a16="http://schemas.microsoft.com/office/drawing/2014/main" id="{DD830F03-742E-1215-75E1-4553DD080192}"/>
-              </a:ext>
-            </a:extLst>
-          </p:cNvPr>
-          <p:cNvCxnSpPr>
-            <a:cxnSpLocks/>
-            <a:stCxn id="4" idx="1"/>
-          </p:cNvCxnSpPr>
-          <p:nvPr/>
-        </p:nvCxnSpPr>
-        <p:spPr>
-          <a:xfrm rot="10800000" flipV="1">
-            <a:off x="9263851" y="1861759"/>
-            <a:ext cx="1398704" cy="316412"/>
-          </a:xfrm>
-          <a:prstGeom prst="curvedConnector3">
-            <a:avLst>
-              <a:gd name="adj1" fmla="val 50000"/>
-            </a:avLst>
-          </a:prstGeom>
-          <a:ln>
-            <a:tailEnd type="triangle"/>
-          </a:ln>
-        </p:spPr>
-        <p:style>
-          <a:lnRef idx="1">
-            <a:schemeClr val="accent1"/>
-          </a:lnRef>
-          <a:fillRef idx="0">
-            <a:schemeClr val="accent1"/>
-          </a:fillRef>
-          <a:effectRef idx="0">
-            <a:schemeClr val="accent1"/>
-          </a:effectRef>
-          <a:fontRef idx="minor">
-            <a:schemeClr val="tx1"/>
-          </a:fontRef>
-        </p:style>
-      </p:cxnSp>
-      <p:cxnSp>
-        <p:nvCxnSpPr>
           <p:cNvPr id="40" name="연결선: 구부러짐 39">
             <a:extLst>
               <a:ext uri="{FF2B5EF4-FFF2-40B4-BE49-F238E27FC236}">
@@ -12508,17 +12465,18 @@
           </p:cNvPr>
           <p:cNvCxnSpPr>
             <a:cxnSpLocks/>
+            <a:stCxn id="23" idx="3"/>
           </p:cNvCxnSpPr>
           <p:nvPr/>
         </p:nvCxnSpPr>
         <p:spPr>
           <a:xfrm flipV="1">
-            <a:off x="9296576" y="1981438"/>
-            <a:ext cx="1360761" cy="316167"/>
+            <a:off x="9158979" y="1981438"/>
+            <a:ext cx="1498358" cy="1300448"/>
           </a:xfrm>
           <a:prstGeom prst="curvedConnector3">
             <a:avLst>
-              <a:gd name="adj1" fmla="val 50000"/>
+              <a:gd name="adj1" fmla="val 14305"/>
             </a:avLst>
           </a:prstGeom>
           <a:ln>
@@ -12540,46 +12498,6 @@
           </a:fontRef>
         </p:style>
       </p:cxnSp>
-      <p:sp>
-        <p:nvSpPr>
-          <p:cNvPr id="44" name="TextBox 43">
-            <a:extLst>
-              <a:ext uri="{FF2B5EF4-FFF2-40B4-BE49-F238E27FC236}">
-                <a16:creationId xmlns:a16="http://schemas.microsoft.com/office/drawing/2014/main" id="{2CB1CEAB-942F-BE3A-4FB1-5A0366452DF3}"/>
-              </a:ext>
-            </a:extLst>
-          </p:cNvPr>
-          <p:cNvSpPr txBox="1"/>
-          <p:nvPr/>
-        </p:nvSpPr>
-        <p:spPr>
-          <a:xfrm>
-            <a:off x="10018956" y="1780396"/>
-            <a:ext cx="549873" cy="184666"/>
-          </a:xfrm>
-          <a:prstGeom prst="rect">
-            <a:avLst/>
-          </a:prstGeom>
-          <a:noFill/>
-        </p:spPr>
-        <p:txBody>
-          <a:bodyPr wrap="square">
-            <a:spAutoFit/>
-          </a:bodyPr>
-          <a:lstStyle/>
-          <a:p>
-            <a:r>
-              <a:rPr lang="en-US" altLang="ko-KR" sz="600" dirty="0" err="1"/>
-              <a:t>subscibe</a:t>
-            </a:r>
-            <a:r>
-              <a:rPr lang="en-US" altLang="ko-KR" sz="600" dirty="0"/>
-              <a:t>()</a:t>
-            </a:r>
-            <a:endParaRPr lang="ko-KR" altLang="en-US" sz="600" dirty="0"/>
-          </a:p>
-        </p:txBody>
-      </p:sp>
       <p:sp>
         <p:nvSpPr>
           <p:cNvPr id="45" name="TextBox 44">
@@ -12616,29 +12534,241 @@
           </a:p>
         </p:txBody>
       </p:sp>
+      <p:sp>
+        <p:nvSpPr>
+          <p:cNvPr id="2" name="직사각형 1">
+            <a:extLst>
+              <a:ext uri="{FF2B5EF4-FFF2-40B4-BE49-F238E27FC236}">
+                <a16:creationId xmlns:a16="http://schemas.microsoft.com/office/drawing/2014/main" id="{31DB615F-2EBF-A700-EECC-2A8EBB910CA1}"/>
+              </a:ext>
+            </a:extLst>
+          </p:cNvPr>
+          <p:cNvSpPr/>
+          <p:nvPr/>
+        </p:nvSpPr>
+        <p:spPr>
+          <a:xfrm>
+            <a:off x="5426015" y="749540"/>
+            <a:ext cx="6689804" cy="3906774"/>
+          </a:xfrm>
+          <a:prstGeom prst="rect">
+            <a:avLst/>
+          </a:prstGeom>
+          <a:noFill/>
+          <a:ln>
+            <a:solidFill>
+              <a:srgbClr val="FFC000"/>
+            </a:solidFill>
+          </a:ln>
+        </p:spPr>
+        <p:style>
+          <a:lnRef idx="2">
+            <a:schemeClr val="accent1">
+              <a:shade val="50000"/>
+            </a:schemeClr>
+          </a:lnRef>
+          <a:fillRef idx="1">
+            <a:schemeClr val="accent1"/>
+          </a:fillRef>
+          <a:effectRef idx="0">
+            <a:schemeClr val="accent1"/>
+          </a:effectRef>
+          <a:fontRef idx="minor">
+            <a:schemeClr val="lt1"/>
+          </a:fontRef>
+        </p:style>
+        <p:txBody>
+          <a:bodyPr rtlCol="0" anchor="ctr"/>
+          <a:lstStyle/>
+          <a:p>
+            <a:pPr algn="ctr"/>
+            <a:endParaRPr lang="ko-KR" altLang="en-US" sz="800" dirty="0">
+              <a:solidFill>
+                <a:schemeClr val="tx1"/>
+              </a:solidFill>
+            </a:endParaRPr>
+          </a:p>
+        </p:txBody>
+      </p:sp>
+      <p:sp>
+        <p:nvSpPr>
+          <p:cNvPr id="5" name="직사각형 4">
+            <a:extLst>
+              <a:ext uri="{FF2B5EF4-FFF2-40B4-BE49-F238E27FC236}">
+                <a16:creationId xmlns:a16="http://schemas.microsoft.com/office/drawing/2014/main" id="{FF1B075B-5A1C-2AE9-5DCB-D060FC360CDB}"/>
+              </a:ext>
+            </a:extLst>
+          </p:cNvPr>
+          <p:cNvSpPr/>
+          <p:nvPr/>
+        </p:nvSpPr>
+        <p:spPr>
+          <a:xfrm>
+            <a:off x="10828125" y="3393873"/>
+            <a:ext cx="1058334" cy="542083"/>
+          </a:xfrm>
+          <a:prstGeom prst="rect">
+            <a:avLst/>
+          </a:prstGeom>
+          <a:noFill/>
+          <a:ln>
+            <a:solidFill>
+              <a:schemeClr val="accent1"/>
+            </a:solidFill>
+          </a:ln>
+        </p:spPr>
+        <p:style>
+          <a:lnRef idx="2">
+            <a:schemeClr val="accent1">
+              <a:shade val="50000"/>
+            </a:schemeClr>
+          </a:lnRef>
+          <a:fillRef idx="1">
+            <a:schemeClr val="accent1"/>
+          </a:fillRef>
+          <a:effectRef idx="0">
+            <a:schemeClr val="accent1"/>
+          </a:effectRef>
+          <a:fontRef idx="minor">
+            <a:schemeClr val="lt1"/>
+          </a:fontRef>
+        </p:style>
+        <p:txBody>
+          <a:bodyPr rtlCol="0" anchor="ctr"/>
+          <a:lstStyle/>
+          <a:p>
+            <a:endParaRPr lang="ko-KR" altLang="en-US" sz="800" dirty="0">
+              <a:solidFill>
+                <a:schemeClr val="tx1"/>
+              </a:solidFill>
+            </a:endParaRPr>
+          </a:p>
+        </p:txBody>
+      </p:sp>
+      <p:sp>
+        <p:nvSpPr>
+          <p:cNvPr id="6" name="직사각형 5">
+            <a:extLst>
+              <a:ext uri="{FF2B5EF4-FFF2-40B4-BE49-F238E27FC236}">
+                <a16:creationId xmlns:a16="http://schemas.microsoft.com/office/drawing/2014/main" id="{4A60C340-6495-FC57-9039-9ED66A7C5F3E}"/>
+              </a:ext>
+            </a:extLst>
+          </p:cNvPr>
+          <p:cNvSpPr/>
+          <p:nvPr/>
+        </p:nvSpPr>
+        <p:spPr>
+          <a:xfrm>
+            <a:off x="9533366" y="3393873"/>
+            <a:ext cx="1058334" cy="546349"/>
+          </a:xfrm>
+          <a:prstGeom prst="rect">
+            <a:avLst/>
+          </a:prstGeom>
+          <a:noFill/>
+          <a:ln>
+            <a:solidFill>
+              <a:schemeClr val="accent1"/>
+            </a:solidFill>
+          </a:ln>
+        </p:spPr>
+        <p:style>
+          <a:lnRef idx="2">
+            <a:schemeClr val="accent1">
+              <a:shade val="50000"/>
+            </a:schemeClr>
+          </a:lnRef>
+          <a:fillRef idx="1">
+            <a:schemeClr val="accent1"/>
+          </a:fillRef>
+          <a:effectRef idx="0">
+            <a:schemeClr val="accent1"/>
+          </a:effectRef>
+          <a:fontRef idx="minor">
+            <a:schemeClr val="lt1"/>
+          </a:fontRef>
+        </p:style>
+        <p:txBody>
+          <a:bodyPr rtlCol="0" anchor="ctr"/>
+          <a:lstStyle/>
+          <a:p>
+            <a:r>
+              <a:rPr lang="en-US" altLang="ko-KR" sz="800" dirty="0">
+                <a:solidFill>
+                  <a:schemeClr val="tx1"/>
+                </a:solidFill>
+              </a:rPr>
+              <a:t>* </a:t>
+            </a:r>
+            <a:r>
+              <a:rPr lang="ko-KR" altLang="en-US" sz="800" dirty="0">
+                <a:solidFill>
+                  <a:schemeClr val="tx1"/>
+                </a:solidFill>
+              </a:rPr>
+              <a:t>정보저장</a:t>
+            </a:r>
+            <a:endParaRPr lang="en-US" altLang="ko-KR" sz="800" dirty="0">
+              <a:solidFill>
+                <a:schemeClr val="tx1"/>
+              </a:solidFill>
+            </a:endParaRPr>
+          </a:p>
+          <a:p>
+            <a:r>
+              <a:rPr lang="en-US" altLang="ko-KR" sz="800" dirty="0">
+                <a:solidFill>
+                  <a:schemeClr val="tx1"/>
+                </a:solidFill>
+              </a:rPr>
+              <a:t>    - Topic</a:t>
+            </a:r>
+          </a:p>
+          <a:p>
+            <a:r>
+              <a:rPr lang="en-US" altLang="ko-KR" sz="800" dirty="0">
+                <a:solidFill>
+                  <a:schemeClr val="tx1"/>
+                </a:solidFill>
+              </a:rPr>
+              <a:t>    - Partition</a:t>
+            </a:r>
+          </a:p>
+          <a:p>
+            <a:r>
+              <a:rPr lang="en-US" altLang="ko-KR" sz="800" dirty="0">
+                <a:solidFill>
+                  <a:schemeClr val="tx1"/>
+                </a:solidFill>
+              </a:rPr>
+              <a:t>    - Offset</a:t>
+            </a:r>
+          </a:p>
+        </p:txBody>
+      </p:sp>
       <p:cxnSp>
         <p:nvCxnSpPr>
-          <p:cNvPr id="46" name="연결선: 구부러짐 45">
+          <p:cNvPr id="11" name="직선 화살표 연결선 10">
             <a:extLst>
               <a:ext uri="{FF2B5EF4-FFF2-40B4-BE49-F238E27FC236}">
-                <a16:creationId xmlns:a16="http://schemas.microsoft.com/office/drawing/2014/main" id="{C6369884-70EF-8DD4-3A7A-D031370359FD}"/>
+                <a16:creationId xmlns:a16="http://schemas.microsoft.com/office/drawing/2014/main" id="{43884A5D-88AE-7D14-67AB-DAB5BBB0F07B}"/>
               </a:ext>
             </a:extLst>
           </p:cNvPr>
           <p:cNvCxnSpPr>
             <a:cxnSpLocks/>
+            <a:stCxn id="4" idx="2"/>
+            <a:endCxn id="5" idx="0"/>
           </p:cNvCxnSpPr>
           <p:nvPr/>
         </p:nvCxnSpPr>
         <p:spPr>
-          <a:xfrm rot="10800000" flipV="1">
-            <a:off x="9262643" y="2080072"/>
-            <a:ext cx="1367187" cy="306159"/>
+          <a:xfrm>
+            <a:off x="11357292" y="2627816"/>
+            <a:ext cx="0" cy="766057"/>
           </a:xfrm>
-          <a:prstGeom prst="curvedConnector3">
-            <a:avLst>
-              <a:gd name="adj1" fmla="val 50000"/>
-            </a:avLst>
+          <a:prstGeom prst="straightConnector1">
+            <a:avLst/>
           </a:prstGeom>
           <a:ln>
             <a:tailEnd type="triangle"/>
@@ -12661,10 +12791,65 @@
       </p:cxnSp>
       <p:sp>
         <p:nvSpPr>
-          <p:cNvPr id="47" name="TextBox 46">
+          <p:cNvPr id="7" name="직사각형 6">
             <a:extLst>
               <a:ext uri="{FF2B5EF4-FFF2-40B4-BE49-F238E27FC236}">
-                <a16:creationId xmlns:a16="http://schemas.microsoft.com/office/drawing/2014/main" id="{33ACE829-630D-A278-FF42-3574A0A3FF81}"/>
+                <a16:creationId xmlns:a16="http://schemas.microsoft.com/office/drawing/2014/main" id="{A0821FE8-9473-0B20-9277-6FA8FD6AB207}"/>
+              </a:ext>
+            </a:extLst>
+          </p:cNvPr>
+          <p:cNvSpPr/>
+          <p:nvPr/>
+        </p:nvSpPr>
+        <p:spPr>
+          <a:xfrm>
+            <a:off x="5621813" y="3393873"/>
+            <a:ext cx="2129062" cy="1117742"/>
+          </a:xfrm>
+          <a:prstGeom prst="rect">
+            <a:avLst/>
+          </a:prstGeom>
+          <a:noFill/>
+          <a:ln>
+            <a:solidFill>
+              <a:schemeClr val="accent1"/>
+            </a:solidFill>
+          </a:ln>
+        </p:spPr>
+        <p:style>
+          <a:lnRef idx="2">
+            <a:schemeClr val="accent1">
+              <a:shade val="50000"/>
+            </a:schemeClr>
+          </a:lnRef>
+          <a:fillRef idx="1">
+            <a:schemeClr val="accent1"/>
+          </a:fillRef>
+          <a:effectRef idx="0">
+            <a:schemeClr val="accent1"/>
+          </a:effectRef>
+          <a:fontRef idx="minor">
+            <a:schemeClr val="lt1"/>
+          </a:fontRef>
+        </p:style>
+        <p:txBody>
+          <a:bodyPr rtlCol="0" anchor="ctr"/>
+          <a:lstStyle/>
+          <a:p>
+            <a:endParaRPr lang="ko-KR" altLang="en-US" sz="800" dirty="0">
+              <a:solidFill>
+                <a:schemeClr val="tx1"/>
+              </a:solidFill>
+            </a:endParaRPr>
+          </a:p>
+        </p:txBody>
+      </p:sp>
+      <p:sp>
+        <p:nvSpPr>
+          <p:cNvPr id="9" name="TextBox 8">
+            <a:extLst>
+              <a:ext uri="{FF2B5EF4-FFF2-40B4-BE49-F238E27FC236}">
+                <a16:creationId xmlns:a16="http://schemas.microsoft.com/office/drawing/2014/main" id="{92AA48D7-8B66-19A1-B8BC-7C497BCD92D1}"/>
               </a:ext>
             </a:extLst>
           </p:cNvPr>
@@ -12673,8 +12858,8 @@
         </p:nvSpPr>
         <p:spPr>
           <a:xfrm>
-            <a:off x="10031952" y="2046398"/>
-            <a:ext cx="549873" cy="184666"/>
+            <a:off x="5600552" y="3174164"/>
+            <a:ext cx="939800" cy="215444"/>
           </a:xfrm>
           <a:prstGeom prst="rect">
             <a:avLst/>
@@ -12688,10 +12873,851 @@
           <a:lstStyle/>
           <a:p>
             <a:r>
-              <a:rPr lang="en-US" altLang="ko-KR" sz="600" dirty="0"/>
-              <a:t>commit</a:t>
-            </a:r>
-            <a:endParaRPr lang="ko-KR" altLang="en-US" sz="600" dirty="0"/>
+              <a:rPr lang="en-US" altLang="ko-KR" sz="800" dirty="0">
+                <a:solidFill>
+                  <a:schemeClr val="tx1"/>
+                </a:solidFill>
+              </a:rPr>
+              <a:t>Fetcher</a:t>
+            </a:r>
+            <a:endParaRPr lang="ko-KR" altLang="en-US" sz="800" dirty="0"/>
+          </a:p>
+        </p:txBody>
+      </p:sp>
+      <p:cxnSp>
+        <p:nvCxnSpPr>
+          <p:cNvPr id="15" name="연결선: 꺾임 14">
+            <a:extLst>
+              <a:ext uri="{FF2B5EF4-FFF2-40B4-BE49-F238E27FC236}">
+                <a16:creationId xmlns:a16="http://schemas.microsoft.com/office/drawing/2014/main" id="{1ABC31CE-9CFE-F4AA-1FFE-556F53DB3475}"/>
+              </a:ext>
+            </a:extLst>
+          </p:cNvPr>
+          <p:cNvCxnSpPr>
+            <a:cxnSpLocks/>
+            <a:stCxn id="4" idx="2"/>
+            <a:endCxn id="19" idx="0"/>
+          </p:cNvCxnSpPr>
+          <p:nvPr/>
+        </p:nvCxnSpPr>
+        <p:spPr>
+          <a:xfrm rot="5400000">
+            <a:off x="10391357" y="2208229"/>
+            <a:ext cx="546348" cy="1385523"/>
+          </a:xfrm>
+          <a:prstGeom prst="bentConnector3">
+            <a:avLst>
+              <a:gd name="adj1" fmla="val 53158"/>
+            </a:avLst>
+          </a:prstGeom>
+          <a:ln>
+            <a:tailEnd type="triangle"/>
+          </a:ln>
+        </p:spPr>
+        <p:style>
+          <a:lnRef idx="1">
+            <a:schemeClr val="accent1"/>
+          </a:lnRef>
+          <a:fillRef idx="0">
+            <a:schemeClr val="accent1"/>
+          </a:fillRef>
+          <a:effectRef idx="0">
+            <a:schemeClr val="accent1"/>
+          </a:effectRef>
+          <a:fontRef idx="minor">
+            <a:schemeClr val="tx1"/>
+          </a:fontRef>
+        </p:style>
+      </p:cxnSp>
+      <p:sp>
+        <p:nvSpPr>
+          <p:cNvPr id="19" name="TextBox 18">
+            <a:extLst>
+              <a:ext uri="{FF2B5EF4-FFF2-40B4-BE49-F238E27FC236}">
+                <a16:creationId xmlns:a16="http://schemas.microsoft.com/office/drawing/2014/main" id="{3359954F-92B7-CA8A-17CD-F1E861D221DE}"/>
+              </a:ext>
+            </a:extLst>
+          </p:cNvPr>
+          <p:cNvSpPr txBox="1"/>
+          <p:nvPr/>
+        </p:nvSpPr>
+        <p:spPr>
+          <a:xfrm>
+            <a:off x="9470723" y="3174164"/>
+            <a:ext cx="1002091" cy="215444"/>
+          </a:xfrm>
+          <a:prstGeom prst="rect">
+            <a:avLst/>
+          </a:prstGeom>
+          <a:noFill/>
+        </p:spPr>
+        <p:txBody>
+          <a:bodyPr wrap="square">
+            <a:spAutoFit/>
+          </a:bodyPr>
+          <a:lstStyle/>
+          <a:p>
+            <a:r>
+              <a:rPr lang="en-US" altLang="ko-KR" sz="800" dirty="0" err="1">
+                <a:solidFill>
+                  <a:schemeClr val="tx1"/>
+                </a:solidFill>
+              </a:rPr>
+              <a:t>SubscriptionState</a:t>
+            </a:r>
+            <a:endParaRPr lang="ko-KR" altLang="en-US" sz="800" dirty="0"/>
+          </a:p>
+        </p:txBody>
+      </p:sp>
+      <p:sp>
+        <p:nvSpPr>
+          <p:cNvPr id="21" name="TextBox 20">
+            <a:extLst>
+              <a:ext uri="{FF2B5EF4-FFF2-40B4-BE49-F238E27FC236}">
+                <a16:creationId xmlns:a16="http://schemas.microsoft.com/office/drawing/2014/main" id="{2D3B1FC4-C37D-BC1E-2D1A-A12E188EA894}"/>
+              </a:ext>
+            </a:extLst>
+          </p:cNvPr>
+          <p:cNvSpPr txBox="1"/>
+          <p:nvPr/>
+        </p:nvSpPr>
+        <p:spPr>
+          <a:xfrm>
+            <a:off x="10743889" y="3174164"/>
+            <a:ext cx="1338452" cy="215444"/>
+          </a:xfrm>
+          <a:prstGeom prst="rect">
+            <a:avLst/>
+          </a:prstGeom>
+          <a:noFill/>
+        </p:spPr>
+        <p:txBody>
+          <a:bodyPr wrap="square">
+            <a:spAutoFit/>
+          </a:bodyPr>
+          <a:lstStyle>
+            <a:defPPr>
+              <a:defRPr lang="ko-KR"/>
+            </a:defPPr>
+            <a:lvl1pPr>
+              <a:defRPr sz="800"/>
+            </a:lvl1pPr>
+          </a:lstStyle>
+          <a:p>
+            <a:r>
+              <a:rPr lang="en-US" altLang="ko-KR" dirty="0" err="1"/>
+              <a:t>ConsumerNetworkClient</a:t>
+            </a:r>
+            <a:endParaRPr lang="ko-KR" altLang="en-US" dirty="0"/>
+          </a:p>
+        </p:txBody>
+      </p:sp>
+      <p:sp>
+        <p:nvSpPr>
+          <p:cNvPr id="22" name="직사각형 21">
+            <a:extLst>
+              <a:ext uri="{FF2B5EF4-FFF2-40B4-BE49-F238E27FC236}">
+                <a16:creationId xmlns:a16="http://schemas.microsoft.com/office/drawing/2014/main" id="{866D10C6-9EB0-EB6C-D284-D0B14ABEB18F}"/>
+              </a:ext>
+            </a:extLst>
+          </p:cNvPr>
+          <p:cNvSpPr/>
+          <p:nvPr/>
+        </p:nvSpPr>
+        <p:spPr>
+          <a:xfrm>
+            <a:off x="8015612" y="3393873"/>
+            <a:ext cx="1184036" cy="546348"/>
+          </a:xfrm>
+          <a:prstGeom prst="rect">
+            <a:avLst/>
+          </a:prstGeom>
+          <a:noFill/>
+          <a:ln>
+            <a:solidFill>
+              <a:schemeClr val="accent1"/>
+            </a:solidFill>
+          </a:ln>
+        </p:spPr>
+        <p:style>
+          <a:lnRef idx="2">
+            <a:schemeClr val="accent1">
+              <a:shade val="50000"/>
+            </a:schemeClr>
+          </a:lnRef>
+          <a:fillRef idx="1">
+            <a:schemeClr val="accent1"/>
+          </a:fillRef>
+          <a:effectRef idx="0">
+            <a:schemeClr val="accent1"/>
+          </a:effectRef>
+          <a:fontRef idx="minor">
+            <a:schemeClr val="lt1"/>
+          </a:fontRef>
+        </p:style>
+        <p:txBody>
+          <a:bodyPr rtlCol="0" anchor="ctr"/>
+          <a:lstStyle/>
+          <a:p>
+            <a:r>
+              <a:rPr lang="en-US" altLang="ko-KR" sz="800" dirty="0">
+                <a:solidFill>
+                  <a:schemeClr val="tx1"/>
+                </a:solidFill>
+              </a:rPr>
+              <a:t>Consumer </a:t>
+            </a:r>
+            <a:r>
+              <a:rPr lang="en-US" altLang="ko-KR" sz="800" dirty="0" err="1">
+                <a:solidFill>
+                  <a:schemeClr val="tx1"/>
+                </a:solidFill>
+              </a:rPr>
+              <a:t>Reblance</a:t>
+            </a:r>
+            <a:br>
+              <a:rPr lang="en-US" altLang="ko-KR" sz="800" dirty="0">
+                <a:solidFill>
+                  <a:schemeClr val="tx1"/>
+                </a:solidFill>
+              </a:rPr>
+            </a:br>
+            <a:r>
+              <a:rPr lang="en-US" altLang="ko-KR" sz="800" dirty="0">
+                <a:solidFill>
+                  <a:schemeClr val="tx1"/>
+                </a:solidFill>
+              </a:rPr>
+              <a:t>Offset </a:t>
+            </a:r>
+            <a:r>
+              <a:rPr lang="ko-KR" altLang="en-US" sz="800" dirty="0">
+                <a:solidFill>
+                  <a:schemeClr val="tx1"/>
+                </a:solidFill>
+              </a:rPr>
+              <a:t>초기화 및 </a:t>
+            </a:r>
+            <a:r>
+              <a:rPr lang="ko-KR" altLang="en-US" sz="800" dirty="0" err="1">
+                <a:solidFill>
+                  <a:schemeClr val="tx1"/>
+                </a:solidFill>
+              </a:rPr>
+              <a:t>커밋</a:t>
+            </a:r>
+            <a:endParaRPr lang="en-US" altLang="ko-KR" sz="800" dirty="0">
+              <a:solidFill>
+                <a:schemeClr val="tx1"/>
+              </a:solidFill>
+            </a:endParaRPr>
+          </a:p>
+        </p:txBody>
+      </p:sp>
+      <p:sp>
+        <p:nvSpPr>
+          <p:cNvPr id="23" name="TextBox 22">
+            <a:extLst>
+              <a:ext uri="{FF2B5EF4-FFF2-40B4-BE49-F238E27FC236}">
+                <a16:creationId xmlns:a16="http://schemas.microsoft.com/office/drawing/2014/main" id="{407FC9C2-2D53-4DB5-495B-F392DC229848}"/>
+              </a:ext>
+            </a:extLst>
+          </p:cNvPr>
+          <p:cNvSpPr txBox="1"/>
+          <p:nvPr/>
+        </p:nvSpPr>
+        <p:spPr>
+          <a:xfrm>
+            <a:off x="7952969" y="3174164"/>
+            <a:ext cx="1206010" cy="215444"/>
+          </a:xfrm>
+          <a:prstGeom prst="rect">
+            <a:avLst/>
+          </a:prstGeom>
+          <a:noFill/>
+        </p:spPr>
+        <p:txBody>
+          <a:bodyPr wrap="square">
+            <a:spAutoFit/>
+          </a:bodyPr>
+          <a:lstStyle/>
+          <a:p>
+            <a:r>
+              <a:rPr lang="en-US" altLang="ko-KR" sz="800" dirty="0" err="1"/>
+              <a:t>ConsumerCoordinator</a:t>
+            </a:r>
+            <a:endParaRPr lang="ko-KR" altLang="en-US" sz="800" dirty="0"/>
+          </a:p>
+        </p:txBody>
+      </p:sp>
+      <p:sp>
+        <p:nvSpPr>
+          <p:cNvPr id="27" name="TextBox 26">
+            <a:extLst>
+              <a:ext uri="{FF2B5EF4-FFF2-40B4-BE49-F238E27FC236}">
+                <a16:creationId xmlns:a16="http://schemas.microsoft.com/office/drawing/2014/main" id="{DB6C3C76-340A-EE3F-4770-58A8EBD9AF70}"/>
+              </a:ext>
+            </a:extLst>
+          </p:cNvPr>
+          <p:cNvSpPr txBox="1"/>
+          <p:nvPr/>
+        </p:nvSpPr>
+        <p:spPr>
+          <a:xfrm>
+            <a:off x="11213440" y="2956588"/>
+            <a:ext cx="196251" cy="215444"/>
+          </a:xfrm>
+          <a:prstGeom prst="rect">
+            <a:avLst/>
+          </a:prstGeom>
+          <a:noFill/>
+        </p:spPr>
+        <p:txBody>
+          <a:bodyPr wrap="square">
+            <a:spAutoFit/>
+          </a:bodyPr>
+          <a:lstStyle>
+            <a:defPPr>
+              <a:defRPr lang="ko-KR"/>
+            </a:defPPr>
+            <a:lvl1pPr>
+              <a:defRPr sz="800"/>
+            </a:lvl1pPr>
+          </a:lstStyle>
+          <a:p>
+            <a:pPr algn="ctr"/>
+            <a:r>
+              <a:rPr lang="ko-KR" altLang="en-US" dirty="0"/>
+              <a:t>①</a:t>
+            </a:r>
+          </a:p>
+        </p:txBody>
+      </p:sp>
+      <p:sp>
+        <p:nvSpPr>
+          <p:cNvPr id="30" name="TextBox 29">
+            <a:extLst>
+              <a:ext uri="{FF2B5EF4-FFF2-40B4-BE49-F238E27FC236}">
+                <a16:creationId xmlns:a16="http://schemas.microsoft.com/office/drawing/2014/main" id="{CD45116B-E852-030E-D7CD-05CF051C97AC}"/>
+              </a:ext>
+            </a:extLst>
+          </p:cNvPr>
+          <p:cNvSpPr txBox="1"/>
+          <p:nvPr/>
+        </p:nvSpPr>
+        <p:spPr>
+          <a:xfrm>
+            <a:off x="9848584" y="2836507"/>
+            <a:ext cx="170372" cy="215444"/>
+          </a:xfrm>
+          <a:prstGeom prst="rect">
+            <a:avLst/>
+          </a:prstGeom>
+          <a:noFill/>
+        </p:spPr>
+        <p:txBody>
+          <a:bodyPr wrap="square">
+            <a:spAutoFit/>
+          </a:bodyPr>
+          <a:lstStyle/>
+          <a:p>
+            <a:pPr algn="ctr"/>
+            <a:r>
+              <a:rPr lang="ko-KR" altLang="en-US" sz="800" dirty="0"/>
+              <a:t>②</a:t>
+            </a:r>
+          </a:p>
+        </p:txBody>
+      </p:sp>
+      <p:cxnSp>
+        <p:nvCxnSpPr>
+          <p:cNvPr id="31" name="연결선: 꺾임 30">
+            <a:extLst>
+              <a:ext uri="{FF2B5EF4-FFF2-40B4-BE49-F238E27FC236}">
+                <a16:creationId xmlns:a16="http://schemas.microsoft.com/office/drawing/2014/main" id="{50525C6D-EB53-EB31-FD31-24BA865FD09D}"/>
+              </a:ext>
+            </a:extLst>
+          </p:cNvPr>
+          <p:cNvCxnSpPr>
+            <a:cxnSpLocks/>
+            <a:stCxn id="4" idx="2"/>
+            <a:endCxn id="23" idx="0"/>
+          </p:cNvCxnSpPr>
+          <p:nvPr/>
+        </p:nvCxnSpPr>
+        <p:spPr>
+          <a:xfrm rot="5400000">
+            <a:off x="9683459" y="1500331"/>
+            <a:ext cx="546348" cy="2801318"/>
+          </a:xfrm>
+          <a:prstGeom prst="bentConnector3">
+            <a:avLst>
+              <a:gd name="adj1" fmla="val 31053"/>
+            </a:avLst>
+          </a:prstGeom>
+          <a:ln>
+            <a:tailEnd type="triangle"/>
+          </a:ln>
+        </p:spPr>
+        <p:style>
+          <a:lnRef idx="1">
+            <a:schemeClr val="accent1"/>
+          </a:lnRef>
+          <a:fillRef idx="0">
+            <a:schemeClr val="accent1"/>
+          </a:fillRef>
+          <a:effectRef idx="0">
+            <a:schemeClr val="accent1"/>
+          </a:effectRef>
+          <a:fontRef idx="minor">
+            <a:schemeClr val="tx1"/>
+          </a:fontRef>
+        </p:style>
+      </p:cxnSp>
+      <p:sp>
+        <p:nvSpPr>
+          <p:cNvPr id="38" name="TextBox 37">
+            <a:extLst>
+              <a:ext uri="{FF2B5EF4-FFF2-40B4-BE49-F238E27FC236}">
+                <a16:creationId xmlns:a16="http://schemas.microsoft.com/office/drawing/2014/main" id="{2B0BBAB2-C571-E36E-98D9-F3BF38FEAAC1}"/>
+              </a:ext>
+            </a:extLst>
+          </p:cNvPr>
+          <p:cNvSpPr txBox="1"/>
+          <p:nvPr/>
+        </p:nvSpPr>
+        <p:spPr>
+          <a:xfrm>
+            <a:off x="8444051" y="2713360"/>
+            <a:ext cx="170372" cy="215444"/>
+          </a:xfrm>
+          <a:prstGeom prst="rect">
+            <a:avLst/>
+          </a:prstGeom>
+          <a:noFill/>
+        </p:spPr>
+        <p:txBody>
+          <a:bodyPr wrap="square">
+            <a:spAutoFit/>
+          </a:bodyPr>
+          <a:lstStyle/>
+          <a:p>
+            <a:pPr algn="ctr"/>
+            <a:r>
+              <a:rPr lang="ko-KR" altLang="en-US" sz="800" dirty="0"/>
+              <a:t>③</a:t>
+            </a:r>
+          </a:p>
+        </p:txBody>
+      </p:sp>
+      <p:cxnSp>
+        <p:nvCxnSpPr>
+          <p:cNvPr id="41" name="연결선: 꺾임 40">
+            <a:extLst>
+              <a:ext uri="{FF2B5EF4-FFF2-40B4-BE49-F238E27FC236}">
+                <a16:creationId xmlns:a16="http://schemas.microsoft.com/office/drawing/2014/main" id="{09EDA930-6988-F6F2-7EC1-C9854F08DCF7}"/>
+              </a:ext>
+            </a:extLst>
+          </p:cNvPr>
+          <p:cNvCxnSpPr>
+            <a:cxnSpLocks/>
+            <a:stCxn id="4" idx="2"/>
+            <a:endCxn id="9" idx="0"/>
+          </p:cNvCxnSpPr>
+          <p:nvPr/>
+        </p:nvCxnSpPr>
+        <p:spPr>
+          <a:xfrm rot="5400000">
+            <a:off x="8440698" y="257570"/>
+            <a:ext cx="546348" cy="5286840"/>
+          </a:xfrm>
+          <a:prstGeom prst="bentConnector3">
+            <a:avLst>
+              <a:gd name="adj1" fmla="val 10527"/>
+            </a:avLst>
+          </a:prstGeom>
+          <a:ln>
+            <a:tailEnd type="triangle"/>
+          </a:ln>
+        </p:spPr>
+        <p:style>
+          <a:lnRef idx="1">
+            <a:schemeClr val="accent1"/>
+          </a:lnRef>
+          <a:fillRef idx="0">
+            <a:schemeClr val="accent1"/>
+          </a:fillRef>
+          <a:effectRef idx="0">
+            <a:schemeClr val="accent1"/>
+          </a:effectRef>
+          <a:fontRef idx="minor">
+            <a:schemeClr val="tx1"/>
+          </a:fontRef>
+        </p:style>
+      </p:cxnSp>
+      <p:sp>
+        <p:nvSpPr>
+          <p:cNvPr id="52" name="TextBox 51">
+            <a:extLst>
+              <a:ext uri="{FF2B5EF4-FFF2-40B4-BE49-F238E27FC236}">
+                <a16:creationId xmlns:a16="http://schemas.microsoft.com/office/drawing/2014/main" id="{25312756-6657-E97C-0811-F91F9C3362A0}"/>
+              </a:ext>
+            </a:extLst>
+          </p:cNvPr>
+          <p:cNvSpPr txBox="1"/>
+          <p:nvPr/>
+        </p:nvSpPr>
+        <p:spPr>
+          <a:xfrm>
+            <a:off x="5937783" y="2565793"/>
+            <a:ext cx="170372" cy="215444"/>
+          </a:xfrm>
+          <a:prstGeom prst="rect">
+            <a:avLst/>
+          </a:prstGeom>
+          <a:noFill/>
+        </p:spPr>
+        <p:txBody>
+          <a:bodyPr wrap="square">
+            <a:spAutoFit/>
+          </a:bodyPr>
+          <a:lstStyle/>
+          <a:p>
+            <a:pPr algn="ctr"/>
+            <a:r>
+              <a:rPr lang="ko-KR" altLang="en-US" sz="800" dirty="0"/>
+              <a:t>④</a:t>
+            </a:r>
+          </a:p>
+        </p:txBody>
+      </p:sp>
+      <p:grpSp>
+        <p:nvGrpSpPr>
+          <p:cNvPr id="198" name="그룹 197">
+            <a:extLst>
+              <a:ext uri="{FF2B5EF4-FFF2-40B4-BE49-F238E27FC236}">
+                <a16:creationId xmlns:a16="http://schemas.microsoft.com/office/drawing/2014/main" id="{36742EA2-4FC7-8614-516F-F9AAAC6E7896}"/>
+              </a:ext>
+            </a:extLst>
+          </p:cNvPr>
+          <p:cNvGrpSpPr/>
+          <p:nvPr/>
+        </p:nvGrpSpPr>
+        <p:grpSpPr>
+          <a:xfrm>
+            <a:off x="2387906" y="502332"/>
+            <a:ext cx="1493813" cy="1747809"/>
+            <a:chOff x="2387906" y="502332"/>
+            <a:chExt cx="1493813" cy="1747809"/>
+          </a:xfrm>
+        </p:grpSpPr>
+        <p:sp>
+          <p:nvSpPr>
+            <p:cNvPr id="167" name="TextBox 166">
+              <a:extLst>
+                <a:ext uri="{FF2B5EF4-FFF2-40B4-BE49-F238E27FC236}">
+                  <a16:creationId xmlns:a16="http://schemas.microsoft.com/office/drawing/2014/main" id="{9707F866-9B5D-6FDA-3099-CD97ED7A4126}"/>
+                </a:ext>
+              </a:extLst>
+            </p:cNvPr>
+            <p:cNvSpPr txBox="1"/>
+            <p:nvPr/>
+          </p:nvSpPr>
+          <p:spPr>
+            <a:xfrm>
+              <a:off x="2698922" y="876996"/>
+              <a:ext cx="703186" cy="230832"/>
+            </a:xfrm>
+            <a:prstGeom prst="rect">
+              <a:avLst/>
+            </a:prstGeom>
+            <a:noFill/>
+          </p:spPr>
+          <p:txBody>
+            <a:bodyPr wrap="square" rtlCol="0">
+              <a:spAutoFit/>
+            </a:bodyPr>
+            <a:lstStyle/>
+            <a:p>
+              <a:r>
+                <a:rPr lang="en-US" altLang="ko-KR" sz="900" dirty="0"/>
+                <a:t>Broker</a:t>
+              </a:r>
+              <a:endParaRPr lang="ko-KR" altLang="en-US" sz="900" dirty="0"/>
+            </a:p>
+          </p:txBody>
+        </p:sp>
+        <p:sp>
+          <p:nvSpPr>
+            <p:cNvPr id="191" name="직사각형 190">
+              <a:extLst>
+                <a:ext uri="{FF2B5EF4-FFF2-40B4-BE49-F238E27FC236}">
+                  <a16:creationId xmlns:a16="http://schemas.microsoft.com/office/drawing/2014/main" id="{584FE788-A7A5-521F-9255-AFF586D913D9}"/>
+                </a:ext>
+              </a:extLst>
+            </p:cNvPr>
+            <p:cNvSpPr/>
+            <p:nvPr/>
+          </p:nvSpPr>
+          <p:spPr>
+            <a:xfrm>
+              <a:off x="2698922" y="1107829"/>
+              <a:ext cx="877996" cy="765796"/>
+            </a:xfrm>
+            <a:prstGeom prst="rect">
+              <a:avLst/>
+            </a:prstGeom>
+            <a:noFill/>
+            <a:ln>
+              <a:solidFill>
+                <a:schemeClr val="accent1"/>
+              </a:solidFill>
+            </a:ln>
+          </p:spPr>
+          <p:style>
+            <a:lnRef idx="2">
+              <a:schemeClr val="accent1">
+                <a:shade val="50000"/>
+              </a:schemeClr>
+            </a:lnRef>
+            <a:fillRef idx="1">
+              <a:schemeClr val="accent1"/>
+            </a:fillRef>
+            <a:effectRef idx="0">
+              <a:schemeClr val="accent1"/>
+            </a:effectRef>
+            <a:fontRef idx="minor">
+              <a:schemeClr val="lt1"/>
+            </a:fontRef>
+          </p:style>
+          <p:txBody>
+            <a:bodyPr rtlCol="0" anchor="ctr"/>
+            <a:lstStyle/>
+            <a:p>
+              <a:pPr algn="ctr"/>
+              <a:endParaRPr lang="ko-KR" altLang="en-US" sz="800" dirty="0">
+                <a:solidFill>
+                  <a:schemeClr val="tx1"/>
+                </a:solidFill>
+              </a:endParaRPr>
+            </a:p>
+          </p:txBody>
+        </p:sp>
+        <p:sp>
+          <p:nvSpPr>
+            <p:cNvPr id="150" name="직사각형 149">
+              <a:extLst>
+                <a:ext uri="{FF2B5EF4-FFF2-40B4-BE49-F238E27FC236}">
+                  <a16:creationId xmlns:a16="http://schemas.microsoft.com/office/drawing/2014/main" id="{CE507046-A25D-8546-ADA2-09EFB7068F4F}"/>
+                </a:ext>
+              </a:extLst>
+            </p:cNvPr>
+            <p:cNvSpPr/>
+            <p:nvPr/>
+          </p:nvSpPr>
+          <p:spPr>
+            <a:xfrm>
+              <a:off x="2402061" y="749540"/>
+              <a:ext cx="1479658" cy="1500601"/>
+            </a:xfrm>
+            <a:prstGeom prst="rect">
+              <a:avLst/>
+            </a:prstGeom>
+            <a:noFill/>
+            <a:ln>
+              <a:solidFill>
+                <a:srgbClr val="FFC000"/>
+              </a:solidFill>
+            </a:ln>
+          </p:spPr>
+          <p:style>
+            <a:lnRef idx="2">
+              <a:schemeClr val="accent1">
+                <a:shade val="50000"/>
+              </a:schemeClr>
+            </a:lnRef>
+            <a:fillRef idx="1">
+              <a:schemeClr val="accent1"/>
+            </a:fillRef>
+            <a:effectRef idx="0">
+              <a:schemeClr val="accent1"/>
+            </a:effectRef>
+            <a:fontRef idx="minor">
+              <a:schemeClr val="lt1"/>
+            </a:fontRef>
+          </p:style>
+          <p:txBody>
+            <a:bodyPr rtlCol="0" anchor="ctr"/>
+            <a:lstStyle/>
+            <a:p>
+              <a:pPr algn="ctr"/>
+              <a:endParaRPr lang="ko-KR" altLang="en-US" sz="800" dirty="0">
+                <a:solidFill>
+                  <a:schemeClr val="tx1"/>
+                </a:solidFill>
+              </a:endParaRPr>
+            </a:p>
+          </p:txBody>
+        </p:sp>
+        <p:sp>
+          <p:nvSpPr>
+            <p:cNvPr id="151" name="TextBox 150">
+              <a:extLst>
+                <a:ext uri="{FF2B5EF4-FFF2-40B4-BE49-F238E27FC236}">
+                  <a16:creationId xmlns:a16="http://schemas.microsoft.com/office/drawing/2014/main" id="{A4F765DA-303E-37B2-BED7-02D92F0CD035}"/>
+                </a:ext>
+              </a:extLst>
+            </p:cNvPr>
+            <p:cNvSpPr txBox="1"/>
+            <p:nvPr/>
+          </p:nvSpPr>
+          <p:spPr>
+            <a:xfrm>
+              <a:off x="2387906" y="502332"/>
+              <a:ext cx="878656" cy="230832"/>
+            </a:xfrm>
+            <a:prstGeom prst="rect">
+              <a:avLst/>
+            </a:prstGeom>
+            <a:noFill/>
+          </p:spPr>
+          <p:txBody>
+            <a:bodyPr wrap="square" rtlCol="0">
+              <a:spAutoFit/>
+            </a:bodyPr>
+            <a:lstStyle/>
+            <a:p>
+              <a:r>
+                <a:rPr lang="en-US" altLang="ko-KR" sz="900" dirty="0"/>
+                <a:t>Kafka Cluster</a:t>
+              </a:r>
+              <a:endParaRPr lang="ko-KR" altLang="en-US" sz="900" dirty="0"/>
+            </a:p>
+          </p:txBody>
+        </p:sp>
+      </p:grpSp>
+      <p:cxnSp>
+        <p:nvCxnSpPr>
+          <p:cNvPr id="154" name="연결선: 구부러짐 153">
+            <a:extLst>
+              <a:ext uri="{FF2B5EF4-FFF2-40B4-BE49-F238E27FC236}">
+                <a16:creationId xmlns:a16="http://schemas.microsoft.com/office/drawing/2014/main" id="{8AD52F47-EDED-EB0E-51D4-F173393B8173}"/>
+              </a:ext>
+            </a:extLst>
+          </p:cNvPr>
+          <p:cNvCxnSpPr>
+            <a:stCxn id="150" idx="2"/>
+            <a:endCxn id="5" idx="2"/>
+          </p:cNvCxnSpPr>
+          <p:nvPr/>
+        </p:nvCxnSpPr>
+        <p:spPr>
+          <a:xfrm rot="16200000" flipH="1">
+            <a:off x="6406684" y="-1014653"/>
+            <a:ext cx="1685815" cy="8215402"/>
+          </a:xfrm>
+          <a:prstGeom prst="curvedConnector3">
+            <a:avLst>
+              <a:gd name="adj1" fmla="val 248650"/>
+            </a:avLst>
+          </a:prstGeom>
+          <a:ln>
+            <a:headEnd type="triangle"/>
+            <a:tailEnd type="triangle"/>
+          </a:ln>
+        </p:spPr>
+        <p:style>
+          <a:lnRef idx="1">
+            <a:schemeClr val="accent1"/>
+          </a:lnRef>
+          <a:fillRef idx="0">
+            <a:schemeClr val="accent1"/>
+          </a:fillRef>
+          <a:effectRef idx="0">
+            <a:schemeClr val="accent1"/>
+          </a:effectRef>
+          <a:fontRef idx="minor">
+            <a:schemeClr val="tx1"/>
+          </a:fontRef>
+        </p:style>
+      </p:cxnSp>
+      <p:sp>
+        <p:nvSpPr>
+          <p:cNvPr id="159" name="원통형 158">
+            <a:extLst>
+              <a:ext uri="{FF2B5EF4-FFF2-40B4-BE49-F238E27FC236}">
+                <a16:creationId xmlns:a16="http://schemas.microsoft.com/office/drawing/2014/main" id="{97EA461B-0E05-866A-4108-CFD4F4C8CEDF}"/>
+              </a:ext>
+            </a:extLst>
+          </p:cNvPr>
+          <p:cNvSpPr/>
+          <p:nvPr/>
+        </p:nvSpPr>
+        <p:spPr>
+          <a:xfrm rot="5400000">
+            <a:off x="6581619" y="3308224"/>
+            <a:ext cx="224287" cy="1246622"/>
+          </a:xfrm>
+          <a:prstGeom prst="can">
+            <a:avLst/>
+          </a:prstGeom>
+          <a:noFill/>
+          <a:ln>
+            <a:solidFill>
+              <a:schemeClr val="tx1"/>
+            </a:solidFill>
+          </a:ln>
+        </p:spPr>
+        <p:style>
+          <a:lnRef idx="2">
+            <a:schemeClr val="accent1">
+              <a:shade val="15000"/>
+            </a:schemeClr>
+          </a:lnRef>
+          <a:fillRef idx="1">
+            <a:schemeClr val="accent1"/>
+          </a:fillRef>
+          <a:effectRef idx="0">
+            <a:schemeClr val="accent1"/>
+          </a:effectRef>
+          <a:fontRef idx="minor">
+            <a:schemeClr val="lt1"/>
+          </a:fontRef>
+        </p:style>
+        <p:txBody>
+          <a:bodyPr vert="vert270" rtlCol="0" anchor="ctr"/>
+          <a:lstStyle/>
+          <a:p>
+            <a:pPr algn="ctr"/>
+            <a:r>
+              <a:rPr lang="en-US" altLang="ko-KR" sz="700" dirty="0">
+                <a:solidFill>
+                  <a:schemeClr val="tx1"/>
+                </a:solidFill>
+              </a:rPr>
+              <a:t>Queue&lt;</a:t>
+            </a:r>
+            <a:r>
+              <a:rPr lang="en-US" altLang="ko-KR" sz="700" dirty="0" err="1">
+                <a:solidFill>
+                  <a:srgbClr val="FF0000"/>
+                </a:solidFill>
+              </a:rPr>
+              <a:t>CompletedFetch</a:t>
+            </a:r>
+            <a:r>
+              <a:rPr lang="en-US" altLang="ko-KR" sz="700" dirty="0">
+                <a:solidFill>
+                  <a:schemeClr val="tx1"/>
+                </a:solidFill>
+              </a:rPr>
+              <a:t>&gt;</a:t>
+            </a:r>
+            <a:endParaRPr lang="ko-KR" altLang="en-US" sz="700" dirty="0">
+              <a:solidFill>
+                <a:schemeClr val="tx1"/>
+              </a:solidFill>
+            </a:endParaRPr>
           </a:p>
         </p:txBody>
       </p:sp>
@@ -12699,6 +13725,78 @@
     <p:extLst>
       <p:ext uri="{BB962C8B-B14F-4D97-AF65-F5344CB8AC3E}">
         <p14:creationId xmlns:p14="http://schemas.microsoft.com/office/powerpoint/2010/main" val="3218083308"/>
+      </p:ext>
+    </p:extLst>
+  </p:cSld>
+  <p:clrMapOvr>
+    <a:masterClrMapping/>
+  </p:clrMapOvr>
+</p:sld>
+</file>
+
+<file path=ppt/slides/slide4.xml><?xml version="1.0" encoding="utf-8"?>
+<p:sld xmlns:a="http://schemas.openxmlformats.org/drawingml/2006/main" xmlns:r="http://schemas.openxmlformats.org/officeDocument/2006/relationships" xmlns:p="http://schemas.openxmlformats.org/presentationml/2006/main">
+  <p:cSld>
+    <p:spTree>
+      <p:nvGrpSpPr>
+        <p:cNvPr id="1" name=""/>
+        <p:cNvGrpSpPr/>
+        <p:nvPr/>
+      </p:nvGrpSpPr>
+      <p:grpSpPr>
+        <a:xfrm>
+          <a:off x="0" y="0"/>
+          <a:ext cx="0" cy="0"/>
+          <a:chOff x="0" y="0"/>
+          <a:chExt cx="0" cy="0"/>
+        </a:xfrm>
+      </p:grpSpPr>
+      <p:sp>
+        <p:nvSpPr>
+          <p:cNvPr id="25" name="TextBox 24">
+            <a:extLst>
+              <a:ext uri="{FF2B5EF4-FFF2-40B4-BE49-F238E27FC236}">
+                <a16:creationId xmlns:a16="http://schemas.microsoft.com/office/drawing/2014/main" id="{0433FC2F-C372-7626-37D0-FF6190D6B906}"/>
+              </a:ext>
+            </a:extLst>
+          </p:cNvPr>
+          <p:cNvSpPr txBox="1"/>
+          <p:nvPr/>
+        </p:nvSpPr>
+        <p:spPr>
+          <a:xfrm>
+            <a:off x="266700" y="327481"/>
+            <a:ext cx="1784485" cy="215444"/>
+          </a:xfrm>
+          <a:prstGeom prst="rect">
+            <a:avLst/>
+          </a:prstGeom>
+          <a:noFill/>
+        </p:spPr>
+        <p:txBody>
+          <a:bodyPr wrap="square">
+            <a:spAutoFit/>
+          </a:bodyPr>
+          <a:lstStyle>
+            <a:defPPr>
+              <a:defRPr lang="ko-KR"/>
+            </a:defPPr>
+            <a:lvl1pPr>
+              <a:defRPr sz="800"/>
+            </a:lvl1pPr>
+          </a:lstStyle>
+          <a:p>
+            <a:r>
+              <a:rPr lang="ko-KR" altLang="en-US" dirty="0"/>
+              <a:t>①②③④⑤⑥⑦⑧⑨⑩</a:t>
+            </a:r>
+          </a:p>
+        </p:txBody>
+      </p:sp>
+    </p:spTree>
+    <p:extLst>
+      <p:ext uri="{BB962C8B-B14F-4D97-AF65-F5344CB8AC3E}">
+        <p14:creationId xmlns:p14="http://schemas.microsoft.com/office/powerpoint/2010/main" val="1575203039"/>
       </p:ext>
     </p:extLst>
   </p:cSld>

</xml_diff>